<commit_message>
docs: slide 4 says the language model, note embeddings in speaker notes
The access gate protects the language model that writes answers; ingestion
still embeds every document for search, so the title no longer implies the
embedding model never sees restricted text.

Co-Authored-By: Claude Opus 5.5 <noreply@anthropic.com>
</commit_message>
<xml_diff>
--- a/docs/presentations/internal-brain-architecture.pptx
+++ b/docs/presentations/internal-brain-architecture.pptx
@@ -121,21 +121,21 @@
   <p:extLst>
     <p:ext uri="{521415D9-36F7-43E2-AB2F-B90AF26B5E84}">
       <p14:sectionLst xmlns:p14="http://schemas.microsoft.com/office/powerpoint/2010/main">
-        <p14:section name="Story" id="{f520bbec-606d-1c50-e252-1d01fc6d35c0}">
+        <p14:section name="Story" id="{6d493d90-7f03-60d8-4626-0f027a7b51af}">
           <p14:sldIdLst>
             <p14:sldId id="256"/>
             <p14:sldId id="257"/>
             <p14:sldId id="258"/>
           </p14:sldIdLst>
         </p14:section>
-        <p14:section name="Architecture" id="{b5892f4c-b397-0d6d-6185-c9bb09481ba2}">
+        <p14:section name="Architecture" id="{10cf7599-0f95-dd5d-3746-77a730cfb8ed}">
           <p14:sldIdLst>
             <p14:sldId id="259"/>
             <p14:sldId id="260"/>
             <p14:sldId id="261"/>
           </p14:sldIdLst>
         </p14:section>
-        <p14:section name="Proof" id="{365c7136-920d-d024-ea8c-6d370e07bbde}">
+        <p14:section name="Proof" id="{081fe7d5-9e61-b198-4b5d-efa5022132a8}">
           <p14:sldIdLst>
             <p14:sldId id="262"/>
             <p14:sldId id="263"/>
@@ -147,7 +147,7 @@
             <p14:sldId id="269"/>
           </p14:sldIdLst>
         </p14:section>
-        <p14:section name="Internal" id="{d0484ad6-48e9-2dbe-f0b1-d03079716c69}">
+        <p14:section name="Internal" id="{ee3001b6-95d9-b36d-4017-7523d35f315e}">
           <p14:sldIdLst>
             <p14:sldId id="270"/>
           </p14:sldIdLst>
@@ -1628,7 +1628,7 @@
           <a:p>
             <a:r>
               <a:rPr lang="en-US" dirty="0"/>
-              <a:t>Walk left to right. Identity is resolved by the server, never trusted from the client. Search over-fetches candidates. The access gate evaluates each document against native permissions reloaded on every query. Only then does anything reach freshness checks, prompt-injection screening and the Tencent ADP model. The red line is the key trust boundary: denied text never crosses it. Verification drops unsupported claims; one hash-chained audit event records the whole decision trail.</a:t>
+              <a:t>Walk left to right. Identity is resolved by the server, never trusted from the client. Search over-fetches candidates. The access gate evaluates each document against native permissions reloaded on every query. Only then does anything reach freshness checks, prompt-injection screening and the Tencent ADP model. The red line is the key trust boundary: denied text never crosses it. Verification drops unsupported claims; one hash-chained audit event records the whole decision trail. Precision for questions: ingestion does embed every document so search works, so the embedding provider processes all content and the vector store is protected like the source data. The gate protects the language model that writes the answer.</a:t>
             </a:r>
             <a:endParaRPr lang="en-US" dirty="0"/>
           </a:p>
@@ -11769,7 +11769,7 @@
                   <a:schemeClr val="tx2"/>
                 </a:solidFill>
               </a:rPr>
-              <a:t>Restricted evidence is removed before the model sees anything</a:t>
+              <a:t>Restricted evidence never reaches the language model</a:t>
             </a:r>
             <a:endParaRPr lang="en-US" sz="2800" dirty="0"/>
           </a:p>

</xml_diff>

<commit_message>
docs: slides 8 and 9 show the recorded reveal for audit answer content
Scenario 5 now says auditors reconstruct decisions directly and see the
answer through a recorded reveal (PR #10); slide 9's audit line and note
match. Status slide lists PR #10 under team agreement.

Co-Authored-By: Claude Opus 5.5 <noreply@anthropic.com>
</commit_message>
<xml_diff>
--- a/docs/presentations/internal-brain-architecture.pptx
+++ b/docs/presentations/internal-brain-architecture.pptx
@@ -121,21 +121,21 @@
   <p:extLst>
     <p:ext uri="{521415D9-36F7-43E2-AB2F-B90AF26B5E84}">
       <p14:sectionLst xmlns:p14="http://schemas.microsoft.com/office/powerpoint/2010/main">
-        <p14:section name="Story" id="{6d493d90-7f03-60d8-4626-0f027a7b51af}">
+        <p14:section name="Story" id="{da5b1e92-e5bb-77df-be84-45971ec08958}">
           <p14:sldIdLst>
             <p14:sldId id="256"/>
             <p14:sldId id="257"/>
             <p14:sldId id="258"/>
           </p14:sldIdLst>
         </p14:section>
-        <p14:section name="Architecture" id="{10cf7599-0f95-dd5d-3746-77a730cfb8ed}">
+        <p14:section name="Architecture" id="{bb8ac8b3-c68c-037e-908c-54d6c94b8d8d}">
           <p14:sldIdLst>
             <p14:sldId id="259"/>
             <p14:sldId id="260"/>
             <p14:sldId id="261"/>
           </p14:sldIdLst>
         </p14:section>
-        <p14:section name="Proof" id="{081fe7d5-9e61-b198-4b5d-efa5022132a8}">
+        <p14:section name="Proof" id="{5c4998ae-d3b5-fd09-6d57-2e39e31d51b2}">
           <p14:sldIdLst>
             <p14:sldId id="262"/>
             <p14:sldId id="263"/>
@@ -147,7 +147,7 @@
             <p14:sldId id="269"/>
           </p14:sldIdLst>
         </p14:section>
-        <p14:section name="Internal" id="{ee3001b6-95d9-b36d-4017-7523d35f315e}">
+        <p14:section name="Internal" id="{cbb9f449-7bd0-cccc-0d8c-a121edb47ac6}">
           <p14:sldIdLst>
             <p14:sldId id="270"/>
           </p14:sldIdLst>
@@ -9898,7 +9898,7 @@
                   <a:schemeClr val="tx1"/>
                 </a:solidFill>
               </a:rPr>
-              <a:t>Access-request approval when the source still blocks the requester (Raphael)</a:t>
+              <a:t>Audit need-to-know with recorded reveal, and approval feedback, PR #10 (Raphael)</a:t>
             </a:r>
             <a:endParaRPr lang="en-US" sz="1350" dirty="0"/>
           </a:p>
@@ -18744,7 +18744,7 @@
                             <a:schemeClr val="tx1"/>
                           </a:solidFill>
                         </a:rPr>
-                        <a:t>Sam, an auditor, reconstructs the question, retrieved IDs, each allow/deny and the answer, and verifies the hash chain</a:t>
+                        <a:t>Sam, an auditor, reconstructs the question, retrieved IDs and each allow/deny; the answer needs a recorded reveal with a reason. The hash chain verifies</a:t>
                       </a:r>
                       <a:endParaRPr lang="en-US" sz="1300" dirty="0"/>
                     </a:p>
@@ -18805,7 +18805,7 @@
                             <a:schemeClr val="accent6"/>
                           </a:solidFill>
                         </a:rPr>
-                        <a:t>test_audit_reconstruction</a:t>
+                        <a:t>test_audit_reconstruction, test_audit_need_to_know</a:t>
                       </a:r>
                       <a:endParaRPr lang="en-US" sz="1100" dirty="0"/>
                     </a:p>
@@ -19435,7 +19435,7 @@
                   <a:schemeClr val="accent5"/>
                 </a:solidFill>
               </a:rPr>
-              <a:t>Audit event a3f9…  ·  chain verified</a:t>
+              <a:t>Audit event a3f9…  ·  chain verified  ·  answer by reveal only</a:t>
             </a:r>
             <a:endParaRPr lang="en-US" sz="1200" dirty="0"/>
           </a:p>
@@ -20021,7 +20021,7 @@
                   <a:schemeClr val="tx1"/>
                 </a:solidFill>
               </a:rPr>
-              <a:t>Opens the hash-chained record a compliance officer can replay.</a:t>
+              <a:t>Opens the hash-chained record. Auditors see every decision; answer text they can't open needs a recorded reveal.</a:t>
             </a:r>
             <a:endParaRPr lang="en-US" sz="1250" dirty="0"/>
           </a:p>

</xml_diff>

<commit_message>
docs: deck matches main and the free demo setup
- Slide 3 and 4: grounding is a deterministic check of every claim,
  numbers and dates included, with no LLM judge (D-013 on main).
- Slide 13: ADP chat with local demo vectors (no text to an embedding
  service), 674 tests on main plus #9 and #10, and the Compose stack is
  ready for a Tencent Cloud server rather than deployed on one.

Co-Authored-By: Claude Opus 5.5 <noreply@anthropic.com>
</commit_message>
<xml_diff>
--- a/docs/presentations/internal-brain-architecture.pptx
+++ b/docs/presentations/internal-brain-architecture.pptx
@@ -121,21 +121,21 @@
   <p:extLst>
     <p:ext uri="{521415D9-36F7-43E2-AB2F-B90AF26B5E84}">
       <p14:sectionLst xmlns:p14="http://schemas.microsoft.com/office/powerpoint/2010/main">
-        <p14:section name="Story" id="{da5b1e92-e5bb-77df-be84-45971ec08958}">
+        <p14:section name="Story" id="{09dfffb1-4c99-7762-13af-58bf22b77de3}">
           <p14:sldIdLst>
             <p14:sldId id="256"/>
             <p14:sldId id="257"/>
             <p14:sldId id="258"/>
           </p14:sldIdLst>
         </p14:section>
-        <p14:section name="Architecture" id="{bb8ac8b3-c68c-037e-908c-54d6c94b8d8d}">
+        <p14:section name="Architecture" id="{8f8efc84-67be-50ed-a310-72cc81deb925}">
           <p14:sldIdLst>
             <p14:sldId id="259"/>
             <p14:sldId id="260"/>
             <p14:sldId id="261"/>
           </p14:sldIdLst>
         </p14:section>
-        <p14:section name="Proof" id="{5c4998ae-d3b5-fd09-6d57-2e39e31d51b2}">
+        <p14:section name="Proof" id="{4929a9ea-bee4-b567-06a7-60ab7fd6c8f3}">
           <p14:sldIdLst>
             <p14:sldId id="262"/>
             <p14:sldId id="263"/>
@@ -147,7 +147,7 @@
             <p14:sldId id="269"/>
           </p14:sldIdLst>
         </p14:section>
-        <p14:section name="Internal" id="{cbb9f449-7bd0-cccc-0d8c-a121edb47ac6}">
+        <p14:section name="Internal" id="{73bedc8b-da14-cfb5-6b1f-fd2815c97a8a}">
           <p14:sldIdLst>
             <p14:sldId id="270"/>
           </p14:sldIdLst>
@@ -8301,7 +8301,7 @@
                   <a:schemeClr val="accent1"/>
                 </a:solidFill>
               </a:rPr>
-              <a:t>573</a:t>
+              <a:t>674</a:t>
             </a:r>
             <a:endParaRPr lang="en-US" sz="4800" dirty="0"/>
           </a:p>
@@ -8615,7 +8615,7 @@
                   <a:schemeClr val="tx1"/>
                 </a:solidFill>
               </a:rPr>
-              <a:t>Tencent Cloud ADP (chat + embeddings) behind a provider factory</a:t>
+              <a:t>Tencent Cloud ADP chat; the demo uses local vectors, so no text goes to an embedding service</a:t>
             </a:r>
             <a:endParaRPr lang="en-US" sz="1350" dirty="0"/>
           </a:p>
@@ -8995,7 +8995,7 @@
                   <a:schemeClr val="tx1"/>
                 </a:solidFill>
               </a:rPr>
-              <a:t>One Docker Compose stack on a Tencent Cloud server</a:t>
+              <a:t>One Docker Compose stack, ready for a single Tencent Cloud server</a:t>
             </a:r>
             <a:endParaRPr lang="en-US" sz="1350" dirty="0"/>
           </a:p>
@@ -9031,7 +9031,7 @@
                   <a:schemeClr val="accent6"/>
                 </a:solidFill>
               </a:rPr>
-              <a:t>Test count: PRs #6 and #9 merged locally, 13 Oct 2026 (11 SQL tests run separately against Postgres).</a:t>
+              <a:t>Test count: main plus PRs #9 and #10, 15 Oct 2026 (11 SQL tests run separately against Postgres).</a:t>
             </a:r>
             <a:endParaRPr lang="en-US" sz="1000" dirty="0"/>
           </a:p>
@@ -11476,7 +11476,7 @@
                   <a:schemeClr val="tx1"/>
                 </a:solidFill>
               </a:rPr>
-              <a:t>Every claim cites its evidence. Unsupported claims are dropped, and the system abstains rather than guesses.</a:t>
+              <a:t>Every claim is checked against its cited evidence, numbers and dates included. Below the bar, the system abstains rather than guesses.</a:t>
             </a:r>
             <a:endParaRPr lang="en-US" sz="1500" dirty="0"/>
           </a:p>
@@ -12848,7 +12848,7 @@
                   <a:schemeClr val="tx1"/>
                 </a:solidFill>
               </a:rPr>
-              <a:t>Check every claim; cite or abstain</a:t>
+              <a:t>Deterministic check of every claim, numbers included; no LLM judge</a:t>
             </a:r>
             <a:endParaRPr lang="en-US" sz="1100" dirty="0"/>
           </a:p>

</xml_diff>

<commit_message>
docs: submission texts, cover image, deck regenerated for John Tan
- docs/submission/SUBMISSION.md: title, blurb and the four form
  sections (overview; real-world insights; solution design incl. how
  prompts drive generation; business value with metrics), worked
  examples, a short description and the form checklist.
- Cover images: cover-380x216.png (form size) and cover-760x432.png.
- Deck .pptx regenerated from the generator after the persona rename
  (#13): slides 7 and 8 said Priya; pronouns reworded neutrally.
- Demo script check label reworded to "the saved answer".

Co-Authored-By: Claude Opus 5.5 <noreply@anthropic.com>
</commit_message>
<xml_diff>
--- a/docs/presentations/internal-brain-architecture.pptx
+++ b/docs/presentations/internal-brain-architecture.pptx
@@ -121,21 +121,21 @@
   <p:extLst>
     <p:ext uri="{521415D9-36F7-43E2-AB2F-B90AF26B5E84}">
       <p14:sectionLst xmlns:p14="http://schemas.microsoft.com/office/powerpoint/2010/main">
-        <p14:section name="Story" id="{09dfffb1-4c99-7762-13af-58bf22b77de3}">
+        <p14:section name="Story" id="{1304e12c-70e2-b0fd-8af5-639057923632}">
           <p14:sldIdLst>
             <p14:sldId id="256"/>
             <p14:sldId id="257"/>
             <p14:sldId id="258"/>
           </p14:sldIdLst>
         </p14:section>
-        <p14:section name="Architecture" id="{8f8efc84-67be-50ed-a310-72cc81deb925}">
+        <p14:section name="Architecture" id="{010221a3-4a54-3141-b290-a7025154fb29}">
           <p14:sldIdLst>
             <p14:sldId id="259"/>
             <p14:sldId id="260"/>
             <p14:sldId id="261"/>
           </p14:sldIdLst>
         </p14:section>
-        <p14:section name="Proof" id="{4929a9ea-bee4-b567-06a7-60ab7fd6c8f3}">
+        <p14:section name="Proof" id="{71d345aa-1ebb-aa9b-b7b3-518787380f84}">
           <p14:sldIdLst>
             <p14:sldId id="262"/>
             <p14:sldId id="263"/>
@@ -147,7 +147,7 @@
             <p14:sldId id="269"/>
           </p14:sldIdLst>
         </p14:section>
-        <p14:section name="Internal" id="{73bedc8b-da14-cfb5-6b1f-fd2815c97a8a}">
+        <p14:section name="Internal" id="{4aa4b61b-2977-2ccd-64ea-aeeab830552f}">
           <p14:sldIdLst>
             <p14:sldId id="270"/>
           </p14:sldIdLst>
@@ -16279,7 +16279,7 @@
                   <a:schemeClr val="accent6"/>
                 </a:solidFill>
               </a:rPr>
-              <a:t>Priya Nair · Finance Ops, Leadership</a:t>
+              <a:t>John Tan · Finance Ops, Leadership</a:t>
             </a:r>
             <a:endParaRPr lang="en-US" sz="1200" dirty="0"/>
           </a:p>
@@ -17067,7 +17067,7 @@
                   <a:schemeClr val="tx1"/>
                 </a:solidFill>
               </a:rPr>
-              <a:t>Priya asks again, then reopens her earlier answer</a:t>
+              <a:t>John asks again, then reopens the earlier answer</a:t>
             </a:r>
             <a:endParaRPr lang="en-US" sz="1400" dirty="0"/>
           </a:p>
@@ -17144,7 +17144,7 @@
                   <a:schemeClr val="accent6"/>
                 </a:solidFill>
               </a:rPr>
-              <a:t>Her saved answer is withheld too</a:t>
+              <a:t>The saved answer is withheld too</a:t>
             </a:r>
             <a:endParaRPr lang="en-US" sz="1300" dirty="0"/>
           </a:p>
@@ -17760,7 +17760,7 @@
                             <a:schemeClr val="tx1"/>
                           </a:solidFill>
                         </a:rPr>
-                        <a:t>Priya asks about the Rail-B cutover. The facts are spread across email, Jira, Slack and Drive; she gets one answer citing several of them</a:t>
+                        <a:t>John asks about the Rail-B cutover. The facts are spread across email, Jira, Slack and Drive, and one answer cites several of them</a:t>
                       </a:r>
                       <a:endParaRPr lang="en-US" sz="1300" dirty="0"/>
                     </a:p>
@@ -18498,7 +18498,7 @@
                             <a:schemeClr val="tx1"/>
                           </a:solidFill>
                         </a:rPr>
-                        <a:t>Leadership is removed from the Drive share (or the in-app grant revoked): Priya's next answer drops the board deck and her saved answer is withheld</a:t>
+                        <a:t>Leadership is removed from the Drive share (or the in-app grant revoked): John's next answer drops the board deck and the saved answer is withheld</a:t>
                       </a:r>
                       <a:endParaRPr lang="en-US" sz="1300" dirty="0"/>
                     </a:p>

</xml_diff>

<commit_message>
docs: submission deck without the internal status slide
build-deck.js skips the internal status slide when DECK_SUBMISSION=1;
internal-brain-architecture-submission.pptx is that 14-slide build.
README and the submission checklist point to it.

Co-Authored-By: Claude Opus 5.5 <noreply@anthropic.com>
</commit_message>
<xml_diff>
--- a/docs/presentations/internal-brain-architecture.pptx
+++ b/docs/presentations/internal-brain-architecture.pptx
@@ -121,21 +121,21 @@
   <p:extLst>
     <p:ext uri="{521415D9-36F7-43E2-AB2F-B90AF26B5E84}">
       <p14:sectionLst xmlns:p14="http://schemas.microsoft.com/office/powerpoint/2010/main">
-        <p14:section name="Story" id="{1304e12c-70e2-b0fd-8af5-639057923632}">
+        <p14:section name="Story" id="{4edd82ed-a426-a36d-d985-25add55d00d3}">
           <p14:sldIdLst>
             <p14:sldId id="256"/>
             <p14:sldId id="257"/>
             <p14:sldId id="258"/>
           </p14:sldIdLst>
         </p14:section>
-        <p14:section name="Architecture" id="{010221a3-4a54-3141-b290-a7025154fb29}">
+        <p14:section name="Architecture" id="{c0adac33-a7de-ecf3-a79f-2311f9a98dee}">
           <p14:sldIdLst>
             <p14:sldId id="259"/>
             <p14:sldId id="260"/>
             <p14:sldId id="261"/>
           </p14:sldIdLst>
         </p14:section>
-        <p14:section name="Proof" id="{71d345aa-1ebb-aa9b-b7b3-518787380f84}">
+        <p14:section name="Proof" id="{3eba4c6e-c4b7-74d8-19b6-1205b7af4168}">
           <p14:sldIdLst>
             <p14:sldId id="262"/>
             <p14:sldId id="263"/>
@@ -147,7 +147,7 @@
             <p14:sldId id="269"/>
           </p14:sldIdLst>
         </p14:section>
-        <p14:section name="Internal" id="{4aa4b61b-2977-2ccd-64ea-aeeab830552f}">
+        <p14:section name="Internal" id="{289d311e-2789-beb2-4518-ee0d30f54141}">
           <p14:sldIdLst>
             <p14:sldId id="270"/>
           </p14:sldIdLst>

</xml_diff>